<commit_message>
test and configuring lab1 and 2
</commit_message>
<xml_diff>
--- a/instructor/modules/Module01-Welcome-Landscape.pptx
+++ b/instructor/modules/Module01-Welcome-Landscape.pptx
@@ -22511,7 +22511,7 @@
                 <a:ea typeface="Courier New" pitchFamily="34" charset="-122"/>
                 <a:cs typeface="Courier New" pitchFamily="34" charset="-120"/>
               </a:rPr>
-              <a:t>github.com/chrisminnick/advanced-react</a:t>
+              <a:t>github.com/chrisminnick/advanced-react-19</a:t>
             </a:r>
             <a:endParaRPr lang="en-US" sz="2200" dirty="0"/>
           </a:p>
@@ -22550,7 +22550,7 @@
                 <a:ea typeface="Arial" pitchFamily="34" charset="-122"/>
                 <a:cs typeface="Arial" pitchFamily="34" charset="-120"/>
               </a:rPr>
-              <a:t>Branch: v2.0   ·   Lab starters live in folders named per project   ·   Solution branches per lab</a:t>
+              <a:t>Version 2.0   ·   Lab starters in lab-files/lab-01 .. lab-08   ·   Reference solutions in solutions/</a:t>
             </a:r>
             <a:endParaRPr lang="en-US" sz="1300" dirty="0"/>
           </a:p>
@@ -22677,7 +22677,7 @@
                 <a:ea typeface="Arial" pitchFamily="34" charset="-122"/>
                 <a:cs typeface="Arial" pitchFamily="34" charset="-120"/>
               </a:rPr>
-              <a:t>real-time-chat, social-media (RR v7 + Next.js), server-components-dashboard</a:t>
+              <a:t>Per-lab folders in lab-files/lab-01 through lab-08 — each fully self-contained</a:t>
             </a:r>
             <a:endParaRPr lang="en-US" sz="1200" dirty="0"/>
           </a:p>
@@ -22765,7 +22765,7 @@
                 <a:ea typeface="Trebuchet MS" pitchFamily="34" charset="-122"/>
                 <a:cs typeface="Trebuchet MS" pitchFamily="34" charset="-120"/>
               </a:rPr>
-              <a:t>Solution branches</a:t>
+              <a:t>Reference solutions</a:t>
             </a:r>
             <a:endParaRPr lang="en-US" sz="1400" dirty="0"/>
           </a:p>
@@ -22804,7 +22804,7 @@
                 <a:ea typeface="Arial" pitchFamily="34" charset="-122"/>
                 <a:cs typeface="Arial" pitchFamily="34" charset="-120"/>
               </a:rPr>
-              <a:t>One per lab — sometimes more than one, when there's a pick-your-tool moment</a:t>
+              <a:t>One folder per lab under solutions/ — sometimes more than one when there's a pick-your-tool moment</a:t>
             </a:r>
             <a:endParaRPr lang="en-US" sz="1200" dirty="0"/>
           </a:p>
@@ -22931,7 +22931,7 @@
                 <a:ea typeface="Arial" pitchFamily="34" charset="-122"/>
                 <a:cs typeface="Arial" pitchFamily="34" charset="-120"/>
               </a:rPr>
-              <a:t>Setup, run instructions, and a LAB-MAP for which lab uses what</a:t>
+              <a:t>Setup, run instructions, and what each lab folder contains</a:t>
             </a:r>
             <a:endParaRPr lang="en-US" sz="1200" dirty="0"/>
           </a:p>

</xml_diff>